<commit_message>
fix(links, qrcode, pdf++): preserve full Portuguese accented URLs, update QR codes and add PDF++ callouts
</commit_message>
<xml_diff>
--- a/content/assets/disciplinas/6-periodo/analise-de-software-orientada-a-objetos/slides_iff_disciplina.pptx
+++ b/content/assets/disciplinas/6-periodo/analise-de-software-orientada-a-objetos/slides_iff_disciplina.pptx
@@ -4033,7 +4033,7 @@
         <p:spPr>
           <a:xfrm>
             <a:off x="3535679" y="1188720"/>
-            <a:ext cx="5120640" cy="5115425"/>
+            <a:ext cx="5120640" cy="5120640"/>
           </a:xfrm>
           <a:prstGeom prst="rect">
             <a:avLst/>
@@ -4071,7 +4071,7 @@
                 <a:latin typeface="Arial"/>
                 <a:hlinkClick r:id="rId3"/>
               </a:rPr>
-              <a:t>https://www.phrandrade.com/pt-br/resource/engenharia-de-computacao/6-periodo/analise-de-software-orientada-a-objetos/anotacoes/atividades/trabalho---coesao-e-acoplamento-asoo/</a:t>
+              <a:t>https://www.phrandrade.com/pt-br/resource/engenharia-de-computação/6-periodo/analise-de-software-orientada-a-objetos/anotações/atividades/trabalho---coesão-e-acoplamento---asoo/</a:t>
             </a:r>
           </a:p>
         </p:txBody>

</xml_diff>